<commit_message>
Update the English BoM draft deck: 579 checks, four-eyes wording
Ten tested areas (case approval and mandatory staff 2FA added), the
four-eyes control now states that the approver never handled the case,
and the internal speaker notes list the three development fixes.

Co-Authored-By: Claude Opus 5.5 <noreply@anthropic.com>
Claude-Session: https://claude.ai/code/session_01ALCBMQrSwdEMnX9x1hQAFX
</commit_message>
<xml_diff>
--- a/outputs/recap/MIPS-platform-BoM-EN-DRAFT.pptx
+++ b/outputs/recap/MIPS-platform-BoM-EN-DRAFT.pptx
@@ -116,13 +116,13 @@
   <p:extLst>
     <p:ext uri="{521415D9-36F7-43E2-AB2F-B90AF26B5E84}">
       <p14:sectionLst xmlns:p14="http://schemas.microsoft.com/office/powerpoint/2010/main">
-        <p14:section name="Overview" id="{6bc2731f-356b-27aa-f8bb-5e22d4e40aaf}">
+        <p14:section name="Overview" id="{5c712321-0696-79dd-b727-b71167c268ae}">
           <p14:sldIdLst>
             <p14:sldId id="256"/>
             <p14:sldId id="257"/>
           </p14:sldIdLst>
         </p14:section>
-        <p14:section name="Platform" id="{3b9134ec-61fd-ae36-7829-5df14e6e48b7}">
+        <p14:section name="Platform" id="{cb4a3165-a049-fbef-6e57-868e480cd28f}">
           <p14:sldIdLst>
             <p14:sldId id="258"/>
             <p14:sldId id="259"/>
@@ -130,7 +130,7 @@
             <p14:sldId id="261"/>
           </p14:sldIdLst>
         </p14:section>
-        <p14:section name="Funds and evidence" id="{81423aae-6eb2-4098-5153-9c63bf8b28c4}">
+        <p14:section name="Funds and evidence" id="{f47da07f-2fd8-e6d7-2aaa-3a9e0204a45c}">
           <p14:sldIdLst>
             <p14:sldId id="262"/>
             <p14:sldId id="263"/>
@@ -1334,7 +1334,7 @@
           <a:p>
             <a:r>
               <a:rPr lang="en-US" dirty="0"/>
-              <a:t>INTERNAL. The tests led to two security fixes in the prototype (sign-in lockout per account instead of per IP; password-change time stored to the microsecond). They are deliberately not described here: development history, not a control. Mention them only if asked how the tests were used. The "2FA mandatory for finance and admin" rule is not covered by the automated tests: the test configuration switches it off.</a:t>
+              <a:t>INTERNAL. The tests led to three fixes in the prototype: sign-in lockout per account instead of per IP; password-change time stored to the microsecond; four-eyes on case decisions extended to everyone who handled the case (an analyst with approver rights could reassign a case and decide it). They are deliberately not described here: development history, not a control. Mention them only if asked how the tests were used. Thirteen deliberate faults introduced in the code were all detected. The mandatory staff 2FA is tested with the rule switched on, as in production.</a:t>
             </a:r>
             <a:endParaRPr lang="en-US" dirty="0"/>
           </a:p>
@@ -3438,7 +3438,7 @@
                 <a:ea typeface="Cambria" pitchFamily="34" charset="-122"/>
                 <a:cs typeface="Cambria" pitchFamily="34" charset="-120"/>
               </a:rPr>
-              <a:t>478</a:t>
+              <a:t>579</a:t>
             </a:r>
             <a:endParaRPr lang="en-US" sz="5000" dirty="0"/>
           </a:p>
@@ -7515,7 +7515,7 @@
                   <a:schemeClr val="tx1"/>
                 </a:solidFill>
               </a:rPr>
-              <a:t>A document is accepted by someone other than its uploader. A case is approved by an approver other than the analyst.</a:t>
+              <a:t>A document is accepted by someone other than its uploader. A case is decided by an approver who never handled it: not its creator, nor any past or present analyst.</a:t>
             </a:r>
             <a:endParaRPr lang="en-US" sz="1300" dirty="0"/>
           </a:p>
@@ -12911,7 +12911,7 @@
                 <a:gridCol w="5669280"/>
                 <a:gridCol w="1005840"/>
               </a:tblGrid>
-              <a:tr h="411480">
+              <a:tr h="393192">
                 <a:tc>
                   <a:txBody>
                     <a:bodyPr/>
@@ -13035,7 +13035,7 @@
                   </a:tcPr>
                 </a:tc>
               </a:tr>
-              <a:tr h="411480">
+              <a:tr h="393192">
                 <a:tc>
                   <a:txBody>
                     <a:bodyPr/>
@@ -13153,7 +13153,7 @@
                   </a:tcPr>
                 </a:tc>
               </a:tr>
-              <a:tr h="411480">
+              <a:tr h="393192">
                 <a:tc>
                   <a:txBody>
                     <a:bodyPr/>
@@ -13271,7 +13271,125 @@
                   </a:tcPr>
                 </a:tc>
               </a:tr>
-              <a:tr h="411480">
+              <a:tr h="393192">
+                <a:tc>
+                  <a:txBody>
+                    <a:bodyPr/>
+                    <a:lstStyle/>
+                    <a:p>
+                      <a:pPr indent="0" marL="0">
+                        <a:buNone/>
+                      </a:pPr>
+                      <a:r>
+                        <a:rPr lang="en-US" sz="1300" dirty="0">
+                          <a:solidFill>
+                            <a:schemeClr val="tx1"/>
+                          </a:solidFill>
+                        </a:rPr>
+                        <a:t>Case approval: each blocker, approver role, four-eyes decision</a:t>
+                      </a:r>
+                      <a:endParaRPr lang="en-US" sz="1300" dirty="0"/>
+                    </a:p>
+                  </a:txBody>
+                  <a:tcPr marL="54864" marR="54864" marT="54864" marB="54864" anchor="ctr">
+                    <a:lnL w="6350" cap="flat" cmpd="sng" algn="ctr">
+                      <a:solidFill>
+                        <a:srgbClr val="D5DDE7"/>
+                      </a:solidFill>
+                      <a:prstDash val="solid"/>
+                      <a:round/>
+                      <a:headEnd type="none" w="med" len="med"/>
+                      <a:tailEnd type="none" w="med" len="med"/>
+                    </a:lnL>
+                    <a:lnR w="6350" cap="flat" cmpd="sng" algn="ctr">
+                      <a:solidFill>
+                        <a:srgbClr val="D5DDE7"/>
+                      </a:solidFill>
+                      <a:prstDash val="solid"/>
+                      <a:round/>
+                      <a:headEnd type="none" w="med" len="med"/>
+                      <a:tailEnd type="none" w="med" len="med"/>
+                    </a:lnR>
+                    <a:lnT w="6350" cap="flat" cmpd="sng" algn="ctr">
+                      <a:solidFill>
+                        <a:srgbClr val="D5DDE7"/>
+                      </a:solidFill>
+                      <a:prstDash val="solid"/>
+                      <a:round/>
+                      <a:headEnd type="none" w="med" len="med"/>
+                      <a:tailEnd type="none" w="med" len="med"/>
+                    </a:lnT>
+                    <a:lnB w="6350" cap="flat" cmpd="sng" algn="ctr">
+                      <a:solidFill>
+                        <a:srgbClr val="D5DDE7"/>
+                      </a:solidFill>
+                      <a:prstDash val="solid"/>
+                      <a:round/>
+                      <a:headEnd type="none" w="med" len="med"/>
+                      <a:tailEnd type="none" w="med" len="med"/>
+                    </a:lnB>
+                  </a:tcPr>
+                </a:tc>
+                <a:tc>
+                  <a:txBody>
+                    <a:bodyPr/>
+                    <a:lstStyle/>
+                    <a:p>
+                      <a:pPr algn="r" indent="0" marL="0">
+                        <a:buNone/>
+                      </a:pPr>
+                      <a:r>
+                        <a:rPr lang="en-US" sz="1300" dirty="0">
+                          <a:solidFill>
+                            <a:schemeClr val="tx1"/>
+                          </a:solidFill>
+                        </a:rPr>
+                        <a:t>78</a:t>
+                      </a:r>
+                      <a:endParaRPr lang="en-US" sz="1300" dirty="0"/>
+                    </a:p>
+                  </a:txBody>
+                  <a:tcPr marL="54864" marR="54864" marT="54864" marB="54864" anchor="ctr">
+                    <a:lnL w="6350" cap="flat" cmpd="sng" algn="ctr">
+                      <a:solidFill>
+                        <a:srgbClr val="D5DDE7"/>
+                      </a:solidFill>
+                      <a:prstDash val="solid"/>
+                      <a:round/>
+                      <a:headEnd type="none" w="med" len="med"/>
+                      <a:tailEnd type="none" w="med" len="med"/>
+                    </a:lnL>
+                    <a:lnR w="6350" cap="flat" cmpd="sng" algn="ctr">
+                      <a:solidFill>
+                        <a:srgbClr val="D5DDE7"/>
+                      </a:solidFill>
+                      <a:prstDash val="solid"/>
+                      <a:round/>
+                      <a:headEnd type="none" w="med" len="med"/>
+                      <a:tailEnd type="none" w="med" len="med"/>
+                    </a:lnR>
+                    <a:lnT w="6350" cap="flat" cmpd="sng" algn="ctr">
+                      <a:solidFill>
+                        <a:srgbClr val="D5DDE7"/>
+                      </a:solidFill>
+                      <a:prstDash val="solid"/>
+                      <a:round/>
+                      <a:headEnd type="none" w="med" len="med"/>
+                      <a:tailEnd type="none" w="med" len="med"/>
+                    </a:lnT>
+                    <a:lnB w="6350" cap="flat" cmpd="sng" algn="ctr">
+                      <a:solidFill>
+                        <a:srgbClr val="D5DDE7"/>
+                      </a:solidFill>
+                      <a:prstDash val="solid"/>
+                      <a:round/>
+                      <a:headEnd type="none" w="med" len="med"/>
+                      <a:tailEnd type="none" w="med" len="med"/>
+                    </a:lnB>
+                  </a:tcPr>
+                </a:tc>
+              </a:tr>
+              <a:tr h="393192">
                 <a:tc>
                   <a:txBody>
                     <a:bodyPr/>
@@ -13389,7 +13507,7 @@
                   </a:tcPr>
                 </a:tc>
               </a:tr>
-              <a:tr h="411480">
+              <a:tr h="393192">
                 <a:tc>
                   <a:txBody>
                     <a:bodyPr/>
@@ -13507,7 +13625,7 @@
                   </a:tcPr>
                 </a:tc>
               </a:tr>
-              <a:tr h="411480">
+              <a:tr h="393192">
                 <a:tc>
                   <a:txBody>
                     <a:bodyPr/>
@@ -13625,7 +13743,7 @@
                   </a:tcPr>
                 </a:tc>
               </a:tr>
-              <a:tr h="411480">
+              <a:tr h="393192">
                 <a:tc>
                   <a:txBody>
                     <a:bodyPr/>
@@ -13743,7 +13861,7 @@
                   </a:tcPr>
                 </a:tc>
               </a:tr>
-              <a:tr h="411480">
+              <a:tr h="393192">
                 <a:tc>
                   <a:txBody>
                     <a:bodyPr/>
@@ -13861,7 +13979,125 @@
                   </a:tcPr>
                 </a:tc>
               </a:tr>
-              <a:tr h="411480">
+              <a:tr h="393192">
+                <a:tc>
+                  <a:txBody>
+                    <a:bodyPr/>
+                    <a:lstStyle/>
+                    <a:p>
+                      <a:pPr indent="0" marL="0">
+                        <a:buNone/>
+                      </a:pPr>
+                      <a:r>
+                        <a:rPr lang="en-US" sz="1300" dirty="0">
+                          <a:solidFill>
+                            <a:schemeClr val="tx1"/>
+                          </a:solidFill>
+                        </a:rPr>
+                        <a:t>Mandatory two-factor authentication for staff</a:t>
+                      </a:r>
+                      <a:endParaRPr lang="en-US" sz="1300" dirty="0"/>
+                    </a:p>
+                  </a:txBody>
+                  <a:tcPr marL="54864" marR="54864" marT="54864" marB="54864" anchor="ctr">
+                    <a:lnL w="6350" cap="flat" cmpd="sng" algn="ctr">
+                      <a:solidFill>
+                        <a:srgbClr val="D5DDE7"/>
+                      </a:solidFill>
+                      <a:prstDash val="solid"/>
+                      <a:round/>
+                      <a:headEnd type="none" w="med" len="med"/>
+                      <a:tailEnd type="none" w="med" len="med"/>
+                    </a:lnL>
+                    <a:lnR w="6350" cap="flat" cmpd="sng" algn="ctr">
+                      <a:solidFill>
+                        <a:srgbClr val="D5DDE7"/>
+                      </a:solidFill>
+                      <a:prstDash val="solid"/>
+                      <a:round/>
+                      <a:headEnd type="none" w="med" len="med"/>
+                      <a:tailEnd type="none" w="med" len="med"/>
+                    </a:lnR>
+                    <a:lnT w="6350" cap="flat" cmpd="sng" algn="ctr">
+                      <a:solidFill>
+                        <a:srgbClr val="D5DDE7"/>
+                      </a:solidFill>
+                      <a:prstDash val="solid"/>
+                      <a:round/>
+                      <a:headEnd type="none" w="med" len="med"/>
+                      <a:tailEnd type="none" w="med" len="med"/>
+                    </a:lnT>
+                    <a:lnB w="6350" cap="flat" cmpd="sng" algn="ctr">
+                      <a:solidFill>
+                        <a:srgbClr val="D5DDE7"/>
+                      </a:solidFill>
+                      <a:prstDash val="solid"/>
+                      <a:round/>
+                      <a:headEnd type="none" w="med" len="med"/>
+                      <a:tailEnd type="none" w="med" len="med"/>
+                    </a:lnB>
+                  </a:tcPr>
+                </a:tc>
+                <a:tc>
+                  <a:txBody>
+                    <a:bodyPr/>
+                    <a:lstStyle/>
+                    <a:p>
+                      <a:pPr algn="r" indent="0" marL="0">
+                        <a:buNone/>
+                      </a:pPr>
+                      <a:r>
+                        <a:rPr lang="en-US" sz="1300" dirty="0">
+                          <a:solidFill>
+                            <a:schemeClr val="tx1"/>
+                          </a:solidFill>
+                        </a:rPr>
+                        <a:t>23</a:t>
+                      </a:r>
+                      <a:endParaRPr lang="en-US" sz="1300" dirty="0"/>
+                    </a:p>
+                  </a:txBody>
+                  <a:tcPr marL="54864" marR="54864" marT="54864" marB="54864" anchor="ctr">
+                    <a:lnL w="6350" cap="flat" cmpd="sng" algn="ctr">
+                      <a:solidFill>
+                        <a:srgbClr val="D5DDE7"/>
+                      </a:solidFill>
+                      <a:prstDash val="solid"/>
+                      <a:round/>
+                      <a:headEnd type="none" w="med" len="med"/>
+                      <a:tailEnd type="none" w="med" len="med"/>
+                    </a:lnL>
+                    <a:lnR w="6350" cap="flat" cmpd="sng" algn="ctr">
+                      <a:solidFill>
+                        <a:srgbClr val="D5DDE7"/>
+                      </a:solidFill>
+                      <a:prstDash val="solid"/>
+                      <a:round/>
+                      <a:headEnd type="none" w="med" len="med"/>
+                      <a:tailEnd type="none" w="med" len="med"/>
+                    </a:lnR>
+                    <a:lnT w="6350" cap="flat" cmpd="sng" algn="ctr">
+                      <a:solidFill>
+                        <a:srgbClr val="D5DDE7"/>
+                      </a:solidFill>
+                      <a:prstDash val="solid"/>
+                      <a:round/>
+                      <a:headEnd type="none" w="med" len="med"/>
+                      <a:tailEnd type="none" w="med" len="med"/>
+                    </a:lnT>
+                    <a:lnB w="6350" cap="flat" cmpd="sng" algn="ctr">
+                      <a:solidFill>
+                        <a:srgbClr val="D5DDE7"/>
+                      </a:solidFill>
+                      <a:prstDash val="solid"/>
+                      <a:round/>
+                      <a:headEnd type="none" w="med" len="med"/>
+                      <a:tailEnd type="none" w="med" len="med"/>
+                    </a:lnB>
+                  </a:tcPr>
+                </a:tc>
+              </a:tr>
+              <a:tr h="393192">
                 <a:tc>
                   <a:txBody>
                     <a:bodyPr/>

</xml_diff>

<commit_message>
English BoM draft: approval step states the stricter four-eyes rule
The onboarding journey slide still read 'approver != analyst'; it now
reads 'approver never involved', and its notes spell out the rule.

Co-Authored-By: Claude Opus 5.5 <noreply@anthropic.com>
Claude-Session: https://claude.ai/code/session_01ALCBMQrSwdEMnX9x1hQAFX
</commit_message>
<xml_diff>
--- a/outputs/recap/MIPS-platform-BoM-EN-DRAFT.pptx
+++ b/outputs/recap/MIPS-platform-BoM-EN-DRAFT.pptx
@@ -116,13 +116,13 @@
   <p:extLst>
     <p:ext uri="{521415D9-36F7-43E2-AB2F-B90AF26B5E84}">
       <p14:sectionLst xmlns:p14="http://schemas.microsoft.com/office/powerpoint/2010/main">
-        <p14:section name="Overview" id="{5c712321-0696-79dd-b727-b71167c268ae}">
+        <p14:section name="Overview" id="{edc8450b-bfb9-f322-92df-a45a55511e19}">
           <p14:sldIdLst>
             <p14:sldId id="256"/>
             <p14:sldId id="257"/>
           </p14:sldIdLst>
         </p14:section>
-        <p14:section name="Platform" id="{cb4a3165-a049-fbef-6e57-868e480cd28f}">
+        <p14:section name="Platform" id="{c4404682-e9f3-6a92-8923-98332d470c60}">
           <p14:sldIdLst>
             <p14:sldId id="258"/>
             <p14:sldId id="259"/>
@@ -130,7 +130,7 @@
             <p14:sldId id="261"/>
           </p14:sldIdLst>
         </p14:section>
-        <p14:section name="Funds and evidence" id="{f47da07f-2fd8-e6d7-2aaa-3a9e0204a45c}">
+        <p14:section name="Funds and evidence" id="{7b7be38a-2764-7d51-774d-c05d294179e9}">
           <p14:sldIdLst>
             <p14:sldId id="262"/>
             <p14:sldId id="263"/>
@@ -894,7 +894,7 @@
           <a:p>
             <a:r>
               <a:rPr lang="en-US" dirty="0"/>
-              <a:t>Approval requires: every required document accepted, at least one director and one beneficial owner, shareholders above the threshold recorded as beneficial owners, every person screened clear, a risk rating (high if a PEP is involved), legal name and BRN. Thresholds are default values pending compliance validation.</a:t>
+              <a:t>Approval requires: every required document accepted, at least one director and one beneficial owner, shareholders above the threshold recorded as beneficial owners, every person screened clear, a risk rating (high if a PEP is involved), legal name and BRN. The decision is taken by an approver who never handled the case: not its creator, analyst or anyone who reassigned it. Thresholds are default values pending compliance validation.</a:t>
             </a:r>
             <a:endParaRPr lang="en-US" dirty="0"/>
           </a:p>
@@ -7052,7 +7052,7 @@
                   <a:schemeClr val="tx2"/>
                 </a:solidFill>
               </a:rPr>
-              <a:t>approver ≠ analyst</a:t>
+              <a:t>approver never involved</a:t>
             </a:r>
             <a:endParaRPr lang="en-US" sz="1200" dirty="0"/>
           </a:p>

</xml_diff>

<commit_message>
English BoM draft: 590 checks with the ClamAV antivirus suite
Adds the antivirus area (ClamAV engine, test signature) to the tested
controls, lists the detection rate as not shown, and states that the
antivirus integration is built and tested but not yet installed.

Co-Authored-By: Claude Opus 5.5 <noreply@anthropic.com>
Claude-Session: https://claude.ai/code/session_01ALCBMQrSwdEMnX9x1hQAFX
</commit_message>
<xml_diff>
--- a/outputs/recap/MIPS-platform-BoM-EN-DRAFT.pptx
+++ b/outputs/recap/MIPS-platform-BoM-EN-DRAFT.pptx
@@ -116,13 +116,13 @@
   <p:extLst>
     <p:ext uri="{521415D9-36F7-43E2-AB2F-B90AF26B5E84}">
       <p14:sectionLst xmlns:p14="http://schemas.microsoft.com/office/powerpoint/2010/main">
-        <p14:section name="Overview" id="{edc8450b-bfb9-f322-92df-a45a55511e19}">
+        <p14:section name="Overview" id="{014dccf2-394f-a1a7-ac89-fdb3e6935ea8}">
           <p14:sldIdLst>
             <p14:sldId id="256"/>
             <p14:sldId id="257"/>
           </p14:sldIdLst>
         </p14:section>
-        <p14:section name="Platform" id="{c4404682-e9f3-6a92-8923-98332d470c60}">
+        <p14:section name="Platform" id="{00db01eb-a321-0082-d769-eb9507105c35}">
           <p14:sldIdLst>
             <p14:sldId id="258"/>
             <p14:sldId id="259"/>
@@ -130,7 +130,7 @@
             <p14:sldId id="261"/>
           </p14:sldIdLst>
         </p14:section>
-        <p14:section name="Funds and evidence" id="{7b7be38a-2764-7d51-774d-c05d294179e9}">
+        <p14:section name="Funds and evidence" id="{a6077f6d-af66-5103-e4d4-189f06fd0e5b}">
           <p14:sldIdLst>
             <p14:sldId id="262"/>
             <p14:sldId id="263"/>
@@ -1334,7 +1334,7 @@
           <a:p>
             <a:r>
               <a:rPr lang="en-US" dirty="0"/>
-              <a:t>INTERNAL. The tests led to three fixes in the prototype: sign-in lockout per account instead of per IP; password-change time stored to the microsecond; four-eyes on case decisions extended to everyone who handled the case (an analyst with approver rights could reassign a case and decide it). They are deliberately not described here: development history, not a control. Mention them only if asked how the tests were used. Thirteen deliberate faults introduced in the code were all detected. The mandatory staff 2FA is tested with the rule switched on, as in production.</a:t>
+              <a:t>INTERNAL. The tests led to three fixes in the prototype: sign-in lockout per account instead of per IP; password-change time stored to the microsecond; four-eyes on case decisions extended to everyone who handled the case (an analyst with approver rights could reassign a case and decide it). They are deliberately not described here: development history, not a control. Mention them only if asked how the tests were used. Fourteen deliberate faults introduced in the code were all detected. The ClamAV suite uses a one-line test signature (EICAR): the official databases could not be downloaded in the test environment. The mandatory staff 2FA is tested with the rule switched on, as in production.</a:t>
             </a:r>
             <a:endParaRPr lang="en-US" dirty="0"/>
           </a:p>
@@ -2922,7 +2922,7 @@
                   <a:schemeClr val="tx1"/>
                 </a:solidFill>
               </a:rPr>
-              <a:t>Scanning of every merchant upload, mandatory before go-live.</a:t>
+              <a:t>ClamAV integration tested (refuses uploads when unavailable); to install with official signatures, mandatory before go-live.</a:t>
             </a:r>
             <a:endParaRPr lang="en-US" sz="1300" dirty="0"/>
           </a:p>
@@ -2958,7 +2958,7 @@
                   <a:schemeClr val="tx2"/>
                 </a:solidFill>
               </a:rPr>
-              <a:t>These items are specified or identified, not built. No timeline is committed in this draft.</a:t>
+              <a:t>These items are specified or identified, not built (the antivirus integration is built and tested, not yet installed). No timeline is committed in this draft.</a:t>
             </a:r>
             <a:endParaRPr lang="en-US" sz="1300" dirty="0"/>
           </a:p>
@@ -3438,7 +3438,7 @@
                 <a:ea typeface="Cambria" pitchFamily="34" charset="-122"/>
                 <a:cs typeface="Cambria" pitchFamily="34" charset="-120"/>
               </a:rPr>
-              <a:t>579</a:t>
+              <a:t>590</a:t>
             </a:r>
             <a:endParaRPr lang="en-US" sz="5000" dirty="0"/>
           </a:p>
@@ -12911,7 +12911,7 @@
                 <a:gridCol w="5669280"/>
                 <a:gridCol w="1005840"/>
               </a:tblGrid>
-              <a:tr h="393192">
+              <a:tr h="365760">
                 <a:tc>
                   <a:txBody>
                     <a:bodyPr/>
@@ -13035,7 +13035,7 @@
                   </a:tcPr>
                 </a:tc>
               </a:tr>
-              <a:tr h="393192">
+              <a:tr h="365760">
                 <a:tc>
                   <a:txBody>
                     <a:bodyPr/>
@@ -13153,7 +13153,7 @@
                   </a:tcPr>
                 </a:tc>
               </a:tr>
-              <a:tr h="393192">
+              <a:tr h="365760">
                 <a:tc>
                   <a:txBody>
                     <a:bodyPr/>
@@ -13271,7 +13271,7 @@
                   </a:tcPr>
                 </a:tc>
               </a:tr>
-              <a:tr h="393192">
+              <a:tr h="365760">
                 <a:tc>
                   <a:txBody>
                     <a:bodyPr/>
@@ -13389,7 +13389,7 @@
                   </a:tcPr>
                 </a:tc>
               </a:tr>
-              <a:tr h="393192">
+              <a:tr h="365760">
                 <a:tc>
                   <a:txBody>
                     <a:bodyPr/>
@@ -13507,7 +13507,7 @@
                   </a:tcPr>
                 </a:tc>
               </a:tr>
-              <a:tr h="393192">
+              <a:tr h="365760">
                 <a:tc>
                   <a:txBody>
                     <a:bodyPr/>
@@ -13625,7 +13625,7 @@
                   </a:tcPr>
                 </a:tc>
               </a:tr>
-              <a:tr h="393192">
+              <a:tr h="365760">
                 <a:tc>
                   <a:txBody>
                     <a:bodyPr/>
@@ -13743,7 +13743,7 @@
                   </a:tcPr>
                 </a:tc>
               </a:tr>
-              <a:tr h="393192">
+              <a:tr h="365760">
                 <a:tc>
                   <a:txBody>
                     <a:bodyPr/>
@@ -13861,7 +13861,7 @@
                   </a:tcPr>
                 </a:tc>
               </a:tr>
-              <a:tr h="393192">
+              <a:tr h="365760">
                 <a:tc>
                   <a:txBody>
                     <a:bodyPr/>
@@ -13979,7 +13979,125 @@
                   </a:tcPr>
                 </a:tc>
               </a:tr>
-              <a:tr h="393192">
+              <a:tr h="365760">
+                <a:tc>
+                  <a:txBody>
+                    <a:bodyPr/>
+                    <a:lstStyle/>
+                    <a:p>
+                      <a:pPr indent="0" marL="0">
+                        <a:buNone/>
+                      </a:pPr>
+                      <a:r>
+                        <a:rPr lang="en-US" sz="1300" dirty="0">
+                          <a:solidFill>
+                            <a:schemeClr val="tx1"/>
+                          </a:solidFill>
+                        </a:rPr>
+                        <a:t>Upload antivirus with the ClamAV engine (test signature)</a:t>
+                      </a:r>
+                      <a:endParaRPr lang="en-US" sz="1300" dirty="0"/>
+                    </a:p>
+                  </a:txBody>
+                  <a:tcPr marL="54864" marR="54864" marT="54864" marB="54864" anchor="ctr">
+                    <a:lnL w="6350" cap="flat" cmpd="sng" algn="ctr">
+                      <a:solidFill>
+                        <a:srgbClr val="D5DDE7"/>
+                      </a:solidFill>
+                      <a:prstDash val="solid"/>
+                      <a:round/>
+                      <a:headEnd type="none" w="med" len="med"/>
+                      <a:tailEnd type="none" w="med" len="med"/>
+                    </a:lnL>
+                    <a:lnR w="6350" cap="flat" cmpd="sng" algn="ctr">
+                      <a:solidFill>
+                        <a:srgbClr val="D5DDE7"/>
+                      </a:solidFill>
+                      <a:prstDash val="solid"/>
+                      <a:round/>
+                      <a:headEnd type="none" w="med" len="med"/>
+                      <a:tailEnd type="none" w="med" len="med"/>
+                    </a:lnR>
+                    <a:lnT w="6350" cap="flat" cmpd="sng" algn="ctr">
+                      <a:solidFill>
+                        <a:srgbClr val="D5DDE7"/>
+                      </a:solidFill>
+                      <a:prstDash val="solid"/>
+                      <a:round/>
+                      <a:headEnd type="none" w="med" len="med"/>
+                      <a:tailEnd type="none" w="med" len="med"/>
+                    </a:lnT>
+                    <a:lnB w="6350" cap="flat" cmpd="sng" algn="ctr">
+                      <a:solidFill>
+                        <a:srgbClr val="D5DDE7"/>
+                      </a:solidFill>
+                      <a:prstDash val="solid"/>
+                      <a:round/>
+                      <a:headEnd type="none" w="med" len="med"/>
+                      <a:tailEnd type="none" w="med" len="med"/>
+                    </a:lnB>
+                  </a:tcPr>
+                </a:tc>
+                <a:tc>
+                  <a:txBody>
+                    <a:bodyPr/>
+                    <a:lstStyle/>
+                    <a:p>
+                      <a:pPr algn="r" indent="0" marL="0">
+                        <a:buNone/>
+                      </a:pPr>
+                      <a:r>
+                        <a:rPr lang="en-US" sz="1300" dirty="0">
+                          <a:solidFill>
+                            <a:schemeClr val="tx1"/>
+                          </a:solidFill>
+                        </a:rPr>
+                        <a:t>11</a:t>
+                      </a:r>
+                      <a:endParaRPr lang="en-US" sz="1300" dirty="0"/>
+                    </a:p>
+                  </a:txBody>
+                  <a:tcPr marL="54864" marR="54864" marT="54864" marB="54864" anchor="ctr">
+                    <a:lnL w="6350" cap="flat" cmpd="sng" algn="ctr">
+                      <a:solidFill>
+                        <a:srgbClr val="D5DDE7"/>
+                      </a:solidFill>
+                      <a:prstDash val="solid"/>
+                      <a:round/>
+                      <a:headEnd type="none" w="med" len="med"/>
+                      <a:tailEnd type="none" w="med" len="med"/>
+                    </a:lnL>
+                    <a:lnR w="6350" cap="flat" cmpd="sng" algn="ctr">
+                      <a:solidFill>
+                        <a:srgbClr val="D5DDE7"/>
+                      </a:solidFill>
+                      <a:prstDash val="solid"/>
+                      <a:round/>
+                      <a:headEnd type="none" w="med" len="med"/>
+                      <a:tailEnd type="none" w="med" len="med"/>
+                    </a:lnR>
+                    <a:lnT w="6350" cap="flat" cmpd="sng" algn="ctr">
+                      <a:solidFill>
+                        <a:srgbClr val="D5DDE7"/>
+                      </a:solidFill>
+                      <a:prstDash val="solid"/>
+                      <a:round/>
+                      <a:headEnd type="none" w="med" len="med"/>
+                      <a:tailEnd type="none" w="med" len="med"/>
+                    </a:lnT>
+                    <a:lnB w="6350" cap="flat" cmpd="sng" algn="ctr">
+                      <a:solidFill>
+                        <a:srgbClr val="D5DDE7"/>
+                      </a:solidFill>
+                      <a:prstDash val="solid"/>
+                      <a:round/>
+                      <a:headEnd type="none" w="med" len="med"/>
+                      <a:tailEnd type="none" w="med" len="med"/>
+                    </a:lnB>
+                  </a:tcPr>
+                </a:tc>
+              </a:tr>
+              <a:tr h="365760">
                 <a:tc>
                   <a:txBody>
                     <a:bodyPr/>
@@ -14097,7 +14215,7 @@
                   </a:tcPr>
                 </a:tc>
               </a:tr>
-              <a:tr h="393192">
+              <a:tr h="365760">
                 <a:tc>
                   <a:txBody>
                     <a:bodyPr/>
@@ -14426,6 +14544,24 @@
                 </a:solidFill>
               </a:rPr>
               <a:t>That business rules (amount units, VAT treatment) are confirmed</a:t>
+            </a:r>
+            <a:endParaRPr lang="en-US" sz="1300" dirty="0"/>
+          </a:p>
+          <a:p>
+            <a:pPr marL="342900" indent="-342900">
+              <a:spcAft>
+                <a:spcPts val="600"/>
+              </a:spcAft>
+              <a:buSzPct val="100000"/>
+              <a:buChar char="•"/>
+            </a:pPr>
+            <a:r>
+              <a:rPr lang="en-US" sz="1300" dirty="0">
+                <a:solidFill>
+                  <a:schemeClr val="tx1"/>
+                </a:solidFill>
+              </a:rPr>
+              <a:t>Antivirus detection rate: a test signature is used, not the official database</a:t>
             </a:r>
             <a:endParaRPr lang="en-US" sz="1300" dirty="0"/>
           </a:p>

</xml_diff>

<commit_message>
English BoM draft: S04d recaptured with ClamAV
Evidence map: antivirus active on the demo only (S04d), with a speaker
note on what 'antivirus OK' means. 'Not yet in place': the antivirus is
built, tested and shown on the demo, not installed in production.

Co-Authored-By: Claude Opus 5.5 <noreply@anthropic.com>
Claude-Session: https://claude.ai/code/session_01ALCBMQrSwdEMnX9x1hQAFX
</commit_message>
<xml_diff>
--- a/outputs/recap/MIPS-platform-BoM-EN-DRAFT.pptx
+++ b/outputs/recap/MIPS-platform-BoM-EN-DRAFT.pptx
@@ -116,13 +116,13 @@
   <p:extLst>
     <p:ext uri="{521415D9-36F7-43E2-AB2F-B90AF26B5E84}">
       <p14:sectionLst xmlns:p14="http://schemas.microsoft.com/office/powerpoint/2010/main">
-        <p14:section name="Overview" id="{014dccf2-394f-a1a7-ac89-fdb3e6935ea8}">
+        <p14:section name="Overview" id="{5dd9d223-20ca-0f3d-f5cc-f3bebfccc7d3}">
           <p14:sldIdLst>
             <p14:sldId id="256"/>
             <p14:sldId id="257"/>
           </p14:sldIdLst>
         </p14:section>
-        <p14:section name="Platform" id="{00db01eb-a321-0082-d769-eb9507105c35}">
+        <p14:section name="Platform" id="{62108798-a0d6-a830-21dc-f7c796eaffd9}">
           <p14:sldIdLst>
             <p14:sldId id="258"/>
             <p14:sldId id="259"/>
@@ -130,7 +130,7 @@
             <p14:sldId id="261"/>
           </p14:sldIdLst>
         </p14:section>
-        <p14:section name="Funds and evidence" id="{a6077f6d-af66-5103-e4d4-189f06fd0e5b}">
+        <p14:section name="Funds and evidence" id="{6f7f51b0-8160-2bf6-d068-9f5810959001}">
           <p14:sldIdLst>
             <p14:sldId id="262"/>
             <p14:sldId id="263"/>
@@ -1246,7 +1246,7 @@
           <a:p>
             <a:r>
               <a:rPr lang="en-US" dirty="0"/>
-              <a:t/>
+              <a:t>S04d was recaptured on 30 October with ClamAV running the official signature databases: each upload shows "antivirus OK", meaning no known signature was detected, not that the file is guaranteed safe. S04c is the same fictitious walkthrough, captured two days earlier.</a:t>
             </a:r>
             <a:endParaRPr lang="en-US" dirty="0"/>
           </a:p>
@@ -2922,7 +2922,7 @@
                   <a:schemeClr val="tx1"/>
                 </a:solidFill>
               </a:rPr>
-              <a:t>ClamAV integration tested (refuses uploads when unavailable); to install with official signatures, mandatory before go-live.</a:t>
+              <a:t>ClamAV integration tested and shown on the demo with official signatures (S04d); to install on the production platform, mandatory before go-live.</a:t>
             </a:r>
             <a:endParaRPr lang="en-US" sz="1300" dirty="0"/>
           </a:p>
@@ -2958,7 +2958,7 @@
                   <a:schemeClr val="tx2"/>
                 </a:solidFill>
               </a:rPr>
-              <a:t>These items are specified or identified, not built (the antivirus integration is built and tested, not yet installed). No timeline is committed in this draft.</a:t>
+              <a:t>Specified or identified, not built (antivirus: built and shown on the demo, not in production). No timeline committed.</a:t>
             </a:r>
             <a:endParaRPr lang="en-US" sz="1300" dirty="0"/>
           </a:p>
@@ -11756,7 +11756,7 @@
                             <a:schemeClr val="tx1"/>
                           </a:solidFill>
                         </a:rPr>
-                        <a:t>Antivirus not installed in the demo</a:t>
+                        <a:t>Antivirus active on the demo only (S04d)</a:t>
                       </a:r>
                       <a:endParaRPr lang="en-US" sz="1300" dirty="0"/>
                     </a:p>

</xml_diff>

<commit_message>
Recap, developer and English BoM decks: model A chosen
French recap (docx, pptx): model A retained on 31 October, model B
not pursued, trust spec not to be developed; the blocking items are now
the licence category and the wallet / transfer flows.
Developer deck: trust module out of the roadmap, decisions updated.
English BoM draft: the fund-flow slide shows the gateway model only, with
what it means for safeguarding and a TO CONFIRM tag for the two checks;
safeguarding reconciliation marked not applicable.

Co-Authored-By: Claude Opus 5.5 <noreply@anthropic.com>
Claude-Session: https://claude.ai/code/session_01ALCBMQrSwdEMnX9x1hQAFX
</commit_message>
<xml_diff>
--- a/outputs/recap/MIPS-platform-BoM-EN-DRAFT.pptx
+++ b/outputs/recap/MIPS-platform-BoM-EN-DRAFT.pptx
@@ -116,13 +116,13 @@
   <p:extLst>
     <p:ext uri="{521415D9-36F7-43E2-AB2F-B90AF26B5E84}">
       <p14:sectionLst xmlns:p14="http://schemas.microsoft.com/office/powerpoint/2010/main">
-        <p14:section name="Overview" id="{5dd9d223-20ca-0f3d-f5cc-f3bebfccc7d3}">
+        <p14:section name="Overview" id="{8bb5c0a1-864a-adf7-6b90-47bd9a37ea4c}">
           <p14:sldIdLst>
             <p14:sldId id="256"/>
             <p14:sldId id="257"/>
           </p14:sldIdLst>
         </p14:section>
-        <p14:section name="Platform" id="{62108798-a0d6-a830-21dc-f7c796eaffd9}">
+        <p14:section name="Platform" id="{15f27ce4-8cc8-2f23-8c12-3bbdc526e33d}">
           <p14:sldIdLst>
             <p14:sldId id="258"/>
             <p14:sldId id="259"/>
@@ -130,7 +130,7 @@
             <p14:sldId id="261"/>
           </p14:sldIdLst>
         </p14:section>
-        <p14:section name="Funds and evidence" id="{6f7f51b0-8160-2bf6-d068-9f5810959001}">
+        <p14:section name="Funds and evidence" id="{ee72e49b-f3ca-a25a-fa5d-51dc02aac245}">
           <p14:sldIdLst>
             <p14:sldId id="262"/>
             <p14:sldId id="263"/>
@@ -1158,7 +1158,7 @@
           <a:p>
             <a:r>
               <a:rPr lang="en-US" dirty="0"/>
-              <a:t>INTERNAL — do not present as is. Model A matches current evidence (no intermediate account, fees invoiced, per-merchant acquirer agreements) but must be confirmed by Finance. Model B is not built. Keep one model on this slide, and check it against the safeguarding requirements of the Bank of Mauritius before submission.</a:t>
+              <a:t>INTERNAL. Gateway model (A) chosen by the CEO on 31 October; collection on behalf of merchants (B) is not pursued unless there is a clear commercial reason. Two blocking checks before submission: (1) Compliance: the licence category applied for must not require holding merchant funds; (2) Finance: no flow (MyT Money, Juice, bank transfer) may go through a MIPS account. Remove the TO CONFIRM tag only when both are confirmed.</a:t>
             </a:r>
             <a:endParaRPr lang="en-US" dirty="0"/>
           </a:p>
@@ -2302,7 +2302,7 @@
                   <a:schemeClr val="tx1"/>
                 </a:solidFill>
               </a:rPr>
-              <a:t>Daily bank-to-ledger-to-merchant-funds reconciliation, needed only if merchant funds are collected (model B).</a:t>
+              <a:t>Not applicable: no merchant funds are held (gateway model). Specified, not built, should funds ever be collected.</a:t>
             </a:r>
             <a:endParaRPr lang="en-US" sz="1300" dirty="0"/>
           </a:p>
@@ -3722,7 +3722,7 @@
                   <a:schemeClr val="tx1"/>
                 </a:solidFill>
               </a:rPr>
-              <a:t>Safeguarding (trust) reconciliation, transaction monitoring, disputes or complaints handling</a:t>
+              <a:t>Transaction monitoring, disputes or complaints handling</a:t>
             </a:r>
             <a:endParaRPr lang="en-US" sz="1400" dirty="0"/>
           </a:p>
@@ -9201,7 +9201,7 @@
                   <a:schemeClr val="tx1"/>
                 </a:solidFill>
               </a:rPr>
-              <a:t>Fund flow model</a:t>
+              <a:t>Fund flow: gateway model, no merchant funds held</a:t>
             </a:r>
             <a:endParaRPr lang="en-US" sz="3000" dirty="0"/>
           </a:p>
@@ -9215,8 +9215,8 @@
         </p:nvSpPr>
         <p:spPr>
           <a:xfrm>
-            <a:off x="6675120" y="411480"/>
-            <a:ext cx="5029200" cy="548640"/>
+            <a:off x="6309360" y="4983480"/>
+            <a:ext cx="5394960" cy="548640"/>
           </a:xfrm>
           <a:prstGeom prst="roundRect">
             <a:avLst>
@@ -9244,8 +9244,8 @@
         </p:nvSpPr>
         <p:spPr>
           <a:xfrm>
-            <a:off x="6675120" y="411480"/>
-            <a:ext cx="5029200" cy="548640"/>
+            <a:off x="6309360" y="4983480"/>
+            <a:ext cx="5394960" cy="548640"/>
           </a:xfrm>
           <a:prstGeom prst="rect">
             <a:avLst/>
@@ -9266,7 +9266,7 @@
                   <a:schemeClr val="accent6"/>
                 </a:solidFill>
               </a:rPr>
-              <a:t>DRAFT — keep only the model chosen before submission</a:t>
+              <a:t>TO CONFIRM: licence category and wallet flows</a:t>
             </a:r>
             <a:endParaRPr lang="en-US" sz="1300" dirty="0"/>
           </a:p>
@@ -9302,7 +9302,7 @@
                   <a:schemeClr val="accent2"/>
                 </a:solidFill>
               </a:rPr>
-              <a:t>A · Gateway: merchants are paid by the acquirer</a:t>
+              <a:t>Merchants are paid directly by the acquirer</a:t>
             </a:r>
             <a:endParaRPr lang="en-US" sz="1600" dirty="0"/>
           </a:p>
@@ -9849,10 +9849,10 @@
             <a:r>
               <a:rPr lang="en-US" sz="1600" b="1" dirty="0">
                 <a:solidFill>
-                  <a:schemeClr val="accent5"/>
-                </a:solidFill>
-              </a:rPr>
-              <a:t>B · Collection on behalf of merchants</a:t>
+                  <a:schemeClr val="accent4"/>
+                </a:solidFill>
+              </a:rPr>
+              <a:t>What this means for safeguarding</a:t>
             </a:r>
             <a:endParaRPr lang="en-US" sz="1600" dirty="0"/>
           </a:p>
@@ -9860,41 +9860,14 @@
       </p:sp>
       <p:sp>
         <p:nvSpPr>
-          <p:cNvPr id="22" name="b1"/>
-          <p:cNvSpPr/>
-          <p:nvPr/>
-        </p:nvSpPr>
-        <p:spPr>
-          <a:xfrm>
-            <a:off x="6309360" y="1783080"/>
-            <a:ext cx="1645920" cy="685800"/>
-          </a:xfrm>
-          <a:prstGeom prst="roundRect">
-            <a:avLst>
-              <a:gd name="adj" fmla="val 10667"/>
-            </a:avLst>
-          </a:prstGeom>
-          <a:solidFill>
-            <a:schemeClr val="bg2"/>
-          </a:solidFill>
-          <a:ln w="9525">
-            <a:solidFill>
-              <a:srgbClr val="C9D3DE"/>
-            </a:solidFill>
-            <a:prstDash val="solid"/>
-          </a:ln>
-        </p:spPr>
-      </p:sp>
-      <p:sp>
-        <p:nvSpPr>
-          <p:cNvPr id="23" name="Text 21"/>
+          <p:cNvPr id="22" name="Text 20"/>
           <p:cNvSpPr txBox="1"/>
           <p:nvPr/>
         </p:nvSpPr>
         <p:spPr>
           <a:xfrm>
-            <a:off x="6309360" y="1783080"/>
-            <a:ext cx="1645920" cy="685800"/>
+            <a:off x="6309360" y="1691640"/>
+            <a:ext cx="5486400" cy="3840480"/>
           </a:xfrm>
           <a:prstGeom prst="rect">
             <a:avLst/>
@@ -9903,506 +9876,7 @@
           <a:ln/>
         </p:spPr>
         <p:txBody>
-          <a:bodyPr wrap="square" lIns="1016" tIns="1016" rIns="1016" bIns="1016" rtlCol="0" anchor="ctr"/>
-          <a:lstStyle/>
-          <a:p>
-            <a:pPr algn="ctr" indent="0" marL="0">
-              <a:buNone/>
-            </a:pPr>
-            <a:r>
-              <a:rPr lang="en-US" sz="1300" dirty="0">
-                <a:solidFill>
-                  <a:schemeClr val="tx1"/>
-                </a:solidFill>
-              </a:rPr>
-              <a:t>Acquirer</a:t>
-            </a:r>
-            <a:endParaRPr lang="en-US" sz="1300" dirty="0"/>
-          </a:p>
-        </p:txBody>
-      </p:sp>
-      <p:sp>
-        <p:nvSpPr>
-          <p:cNvPr id="24" name="b2"/>
-          <p:cNvSpPr/>
-          <p:nvPr/>
-        </p:nvSpPr>
-        <p:spPr>
-          <a:xfrm>
-            <a:off x="8229600" y="1783080"/>
-            <a:ext cx="1645920" cy="685800"/>
-          </a:xfrm>
-          <a:prstGeom prst="roundRect">
-            <a:avLst>
-              <a:gd name="adj" fmla="val 10667"/>
-            </a:avLst>
-          </a:prstGeom>
-          <a:solidFill>
-            <a:schemeClr val="accent5">
-              <a:alpha val="20000"/>
-            </a:schemeClr>
-          </a:solidFill>
-          <a:ln w="9525">
-            <a:solidFill>
-              <a:schemeClr val="accent5"/>
-            </a:solidFill>
-            <a:prstDash val="solid"/>
-          </a:ln>
-        </p:spPr>
-      </p:sp>
-      <p:sp>
-        <p:nvSpPr>
-          <p:cNvPr id="25" name="Text 23"/>
-          <p:cNvSpPr txBox="1"/>
-          <p:nvPr/>
-        </p:nvSpPr>
-        <p:spPr>
-          <a:xfrm>
-            <a:off x="8229600" y="1783080"/>
-            <a:ext cx="1645920" cy="685800"/>
-          </a:xfrm>
-          <a:prstGeom prst="rect">
-            <a:avLst/>
-          </a:prstGeom>
-          <a:noFill/>
-          <a:ln/>
-        </p:spPr>
-        <p:txBody>
-          <a:bodyPr wrap="square" lIns="1016" tIns="1016" rIns="1016" bIns="1016" rtlCol="0" anchor="ctr"/>
-          <a:lstStyle/>
-          <a:p>
-            <a:pPr algn="ctr" indent="0" marL="0">
-              <a:buNone/>
-            </a:pPr>
-            <a:r>
-              <a:rPr lang="en-US" sz="1300" dirty="0">
-                <a:solidFill>
-                  <a:schemeClr val="tx1"/>
-                </a:solidFill>
-              </a:rPr>
-              <a:t>Trust account</a:t>
-            </a:r>
-            <a:endParaRPr lang="en-US" sz="1300" dirty="0"/>
-          </a:p>
-          <a:p>
-            <a:pPr algn="ctr" indent="0" marL="0">
-              <a:buNone/>
-            </a:pPr>
-            <a:r>
-              <a:rPr lang="en-US" sz="1300" dirty="0">
-                <a:solidFill>
-                  <a:schemeClr val="tx1"/>
-                </a:solidFill>
-              </a:rPr>
-              <a:t>MUR</a:t>
-            </a:r>
-            <a:endParaRPr lang="en-US" sz="1300" dirty="0"/>
-          </a:p>
-        </p:txBody>
-      </p:sp>
-      <p:sp>
-        <p:nvSpPr>
-          <p:cNvPr id="26" name="b3"/>
-          <p:cNvSpPr/>
-          <p:nvPr/>
-        </p:nvSpPr>
-        <p:spPr>
-          <a:xfrm>
-            <a:off x="10149840" y="1783080"/>
-            <a:ext cx="1645920" cy="685800"/>
-          </a:xfrm>
-          <a:prstGeom prst="roundRect">
-            <a:avLst>
-              <a:gd name="adj" fmla="val 10667"/>
-            </a:avLst>
-          </a:prstGeom>
-          <a:solidFill>
-            <a:schemeClr val="accent3">
-              <a:alpha val="15000"/>
-            </a:schemeClr>
-          </a:solidFill>
-          <a:ln w="9525">
-            <a:solidFill>
-              <a:schemeClr val="accent3"/>
-            </a:solidFill>
-            <a:prstDash val="solid"/>
-          </a:ln>
-        </p:spPr>
-      </p:sp>
-      <p:sp>
-        <p:nvSpPr>
-          <p:cNvPr id="27" name="Text 25"/>
-          <p:cNvSpPr txBox="1"/>
-          <p:nvPr/>
-        </p:nvSpPr>
-        <p:spPr>
-          <a:xfrm>
-            <a:off x="10149840" y="1783080"/>
-            <a:ext cx="1645920" cy="685800"/>
-          </a:xfrm>
-          <a:prstGeom prst="rect">
-            <a:avLst/>
-          </a:prstGeom>
-          <a:noFill/>
-          <a:ln/>
-        </p:spPr>
-        <p:txBody>
-          <a:bodyPr wrap="square" lIns="1016" tIns="1016" rIns="1016" bIns="1016" rtlCol="0" anchor="ctr"/>
-          <a:lstStyle/>
-          <a:p>
-            <a:pPr algn="ctr" indent="0" marL="0">
-              <a:buNone/>
-            </a:pPr>
-            <a:r>
-              <a:rPr lang="en-US" sz="1300" dirty="0">
-                <a:solidFill>
-                  <a:schemeClr val="tx1"/>
-                </a:solidFill>
-              </a:rPr>
-              <a:t>Merchants</a:t>
-            </a:r>
-            <a:endParaRPr lang="en-US" sz="1300" dirty="0"/>
-          </a:p>
-        </p:txBody>
-      </p:sp>
-      <p:sp>
-        <p:nvSpPr>
-          <p:cNvPr id="28" name="b4"/>
-          <p:cNvSpPr/>
-          <p:nvPr/>
-        </p:nvSpPr>
-        <p:spPr>
-          <a:xfrm>
-            <a:off x="8229600" y="3154680"/>
-            <a:ext cx="1645920" cy="685800"/>
-          </a:xfrm>
-          <a:prstGeom prst="roundRect">
-            <a:avLst>
-              <a:gd name="adj" fmla="val 10667"/>
-            </a:avLst>
-          </a:prstGeom>
-          <a:solidFill>
-            <a:schemeClr val="accent2">
-              <a:alpha val="15000"/>
-            </a:schemeClr>
-          </a:solidFill>
-          <a:ln w="9525">
-            <a:solidFill>
-              <a:schemeClr val="accent2"/>
-            </a:solidFill>
-            <a:prstDash val="solid"/>
-          </a:ln>
-        </p:spPr>
-      </p:sp>
-      <p:sp>
-        <p:nvSpPr>
-          <p:cNvPr id="29" name="Text 27"/>
-          <p:cNvSpPr txBox="1"/>
-          <p:nvPr/>
-        </p:nvSpPr>
-        <p:spPr>
-          <a:xfrm>
-            <a:off x="8229600" y="3154680"/>
-            <a:ext cx="1645920" cy="685800"/>
-          </a:xfrm>
-          <a:prstGeom prst="rect">
-            <a:avLst/>
-          </a:prstGeom>
-          <a:noFill/>
-          <a:ln/>
-        </p:spPr>
-        <p:txBody>
-          <a:bodyPr wrap="square" lIns="1016" tIns="1016" rIns="1016" bIns="1016" rtlCol="0" anchor="ctr"/>
-          <a:lstStyle/>
-          <a:p>
-            <a:pPr algn="ctr" indent="0" marL="0">
-              <a:buNone/>
-            </a:pPr>
-            <a:r>
-              <a:rPr lang="en-US" sz="1300" dirty="0">
-                <a:solidFill>
-                  <a:schemeClr val="tx1"/>
-                </a:solidFill>
-              </a:rPr>
-              <a:t>Operating</a:t>
-            </a:r>
-            <a:endParaRPr lang="en-US" sz="1300" dirty="0"/>
-          </a:p>
-          <a:p>
-            <a:pPr algn="ctr" indent="0" marL="0">
-              <a:buNone/>
-            </a:pPr>
-            <a:r>
-              <a:rPr lang="en-US" sz="1300" dirty="0">
-                <a:solidFill>
-                  <a:schemeClr val="tx1"/>
-                </a:solidFill>
-              </a:rPr>
-              <a:t>account</a:t>
-            </a:r>
-            <a:endParaRPr lang="en-US" sz="1300" dirty="0"/>
-          </a:p>
-        </p:txBody>
-      </p:sp>
-      <p:sp>
-        <p:nvSpPr>
-          <p:cNvPr id="30" name="Shape 28"/>
-          <p:cNvSpPr/>
-          <p:nvPr/>
-        </p:nvSpPr>
-        <p:spPr>
-          <a:xfrm>
-            <a:off x="7973568" y="2121408"/>
-            <a:ext cx="237744" cy="0"/>
-          </a:xfrm>
-          <a:prstGeom prst="line">
-            <a:avLst/>
-          </a:prstGeom>
-          <a:noFill/>
-          <a:ln w="19050">
-            <a:solidFill>
-              <a:schemeClr val="tx2"/>
-            </a:solidFill>
-            <a:prstDash val="solid"/>
-            <a:tailEnd type="triangle"/>
-          </a:ln>
-        </p:spPr>
-      </p:sp>
-      <p:sp>
-        <p:nvSpPr>
-          <p:cNvPr id="31" name="Text 29"/>
-          <p:cNvSpPr txBox="1"/>
-          <p:nvPr/>
-        </p:nvSpPr>
-        <p:spPr>
-          <a:xfrm>
-            <a:off x="7589520" y="1508760"/>
-            <a:ext cx="1005840" cy="274320"/>
-          </a:xfrm>
-          <a:prstGeom prst="rect">
-            <a:avLst/>
-          </a:prstGeom>
-          <a:noFill/>
-          <a:ln/>
-        </p:spPr>
-        <p:txBody>
-          <a:bodyPr wrap="square" lIns="0" tIns="0" rIns="0" bIns="0" rtlCol="0" anchor="t"/>
-          <a:lstStyle/>
-          <a:p>
-            <a:pPr algn="ctr" indent="0" marL="0">
-              <a:buNone/>
-            </a:pPr>
-            <a:r>
-              <a:rPr lang="en-US" sz="1100" dirty="0">
-                <a:solidFill>
-                  <a:schemeClr val="tx2"/>
-                </a:solidFill>
-              </a:rPr>
-              <a:t>gross, D+1</a:t>
-            </a:r>
-            <a:endParaRPr lang="en-US" sz="1100" dirty="0"/>
-          </a:p>
-        </p:txBody>
-      </p:sp>
-      <p:sp>
-        <p:nvSpPr>
-          <p:cNvPr id="32" name="Shape 30"/>
-          <p:cNvSpPr/>
-          <p:nvPr/>
-        </p:nvSpPr>
-        <p:spPr>
-          <a:xfrm>
-            <a:off x="9893808" y="2121408"/>
-            <a:ext cx="237744" cy="0"/>
-          </a:xfrm>
-          <a:prstGeom prst="line">
-            <a:avLst/>
-          </a:prstGeom>
-          <a:noFill/>
-          <a:ln w="19050">
-            <a:solidFill>
-              <a:schemeClr val="tx2"/>
-            </a:solidFill>
-            <a:prstDash val="solid"/>
-            <a:tailEnd type="triangle"/>
-          </a:ln>
-        </p:spPr>
-      </p:sp>
-      <p:sp>
-        <p:nvSpPr>
-          <p:cNvPr id="33" name="Text 31"/>
-          <p:cNvSpPr txBox="1"/>
-          <p:nvPr/>
-        </p:nvSpPr>
-        <p:spPr>
-          <a:xfrm>
-            <a:off x="9509760" y="1508760"/>
-            <a:ext cx="1005840" cy="274320"/>
-          </a:xfrm>
-          <a:prstGeom prst="rect">
-            <a:avLst/>
-          </a:prstGeom>
-          <a:noFill/>
-          <a:ln/>
-        </p:spPr>
-        <p:txBody>
-          <a:bodyPr wrap="square" lIns="0" tIns="0" rIns="0" bIns="0" rtlCol="0" anchor="t"/>
-          <a:lstStyle/>
-          <a:p>
-            <a:pPr algn="ctr" indent="0" marL="0">
-              <a:buNone/>
-            </a:pPr>
-            <a:r>
-              <a:rPr lang="en-US" sz="1100" dirty="0">
-                <a:solidFill>
-                  <a:schemeClr val="tx2"/>
-                </a:solidFill>
-              </a:rPr>
-              <a:t>net, D+1</a:t>
-            </a:r>
-            <a:endParaRPr lang="en-US" sz="1100" dirty="0"/>
-          </a:p>
-        </p:txBody>
-      </p:sp>
-      <p:sp>
-        <p:nvSpPr>
-          <p:cNvPr id="34" name="Shape 32"/>
-          <p:cNvSpPr/>
-          <p:nvPr/>
-        </p:nvSpPr>
-        <p:spPr>
-          <a:xfrm>
-            <a:off x="8778240" y="2487168"/>
-            <a:ext cx="0" cy="649224"/>
-          </a:xfrm>
-          <a:prstGeom prst="line">
-            <a:avLst/>
-          </a:prstGeom>
-          <a:noFill/>
-          <a:ln w="19050">
-            <a:solidFill>
-              <a:schemeClr val="tx2"/>
-            </a:solidFill>
-            <a:prstDash val="solid"/>
-            <a:tailEnd type="triangle"/>
-          </a:ln>
-        </p:spPr>
-      </p:sp>
-      <p:sp>
-        <p:nvSpPr>
-          <p:cNvPr id="35" name="Text 33"/>
-          <p:cNvSpPr txBox="1"/>
-          <p:nvPr/>
-        </p:nvSpPr>
-        <p:spPr>
-          <a:xfrm>
-            <a:off x="7680960" y="2697480"/>
-            <a:ext cx="1051560" cy="274320"/>
-          </a:xfrm>
-          <a:prstGeom prst="rect">
-            <a:avLst/>
-          </a:prstGeom>
-          <a:noFill/>
-          <a:ln/>
-        </p:spPr>
-        <p:txBody>
-          <a:bodyPr wrap="square" lIns="0" tIns="0" rIns="0" bIns="0" rtlCol="0" anchor="t"/>
-          <a:lstStyle/>
-          <a:p>
-            <a:pPr algn="r" indent="0" marL="0">
-              <a:buNone/>
-            </a:pPr>
-            <a:r>
-              <a:rPr lang="en-US" sz="1100" dirty="0">
-                <a:solidFill>
-                  <a:schemeClr val="tx2"/>
-                </a:solidFill>
-              </a:rPr>
-              <a:t>fees</a:t>
-            </a:r>
-            <a:endParaRPr lang="en-US" sz="1100" dirty="0"/>
-          </a:p>
-        </p:txBody>
-      </p:sp>
-      <p:sp>
-        <p:nvSpPr>
-          <p:cNvPr id="36" name="Shape 34"/>
-          <p:cNvSpPr/>
-          <p:nvPr/>
-        </p:nvSpPr>
-        <p:spPr>
-          <a:xfrm flipV="1">
-            <a:off x="9326880" y="2487168"/>
-            <a:ext cx="0" cy="649224"/>
-          </a:xfrm>
-          <a:prstGeom prst="line">
-            <a:avLst/>
-          </a:prstGeom>
-          <a:noFill/>
-          <a:ln w="19050">
-            <a:solidFill>
-              <a:schemeClr val="tx2"/>
-            </a:solidFill>
-            <a:prstDash val="dash"/>
-            <a:tailEnd type="triangle"/>
-          </a:ln>
-        </p:spPr>
-      </p:sp>
-      <p:sp>
-        <p:nvSpPr>
-          <p:cNvPr id="37" name="Text 35"/>
-          <p:cNvSpPr txBox="1"/>
-          <p:nvPr/>
-        </p:nvSpPr>
-        <p:spPr>
-          <a:xfrm>
-            <a:off x="9372600" y="2697480"/>
-            <a:ext cx="1280160" cy="274320"/>
-          </a:xfrm>
-          <a:prstGeom prst="rect">
-            <a:avLst/>
-          </a:prstGeom>
-          <a:noFill/>
-          <a:ln/>
-        </p:spPr>
-        <p:txBody>
-          <a:bodyPr wrap="square" lIns="0" tIns="0" rIns="0" bIns="0" rtlCol="0" anchor="t"/>
-          <a:lstStyle/>
-          <a:p>
-            <a:pPr algn="l" indent="0" marL="0">
-              <a:buNone/>
-            </a:pPr>
-            <a:r>
-              <a:rPr lang="en-US" sz="1100" dirty="0">
-                <a:solidFill>
-                  <a:schemeClr val="tx2"/>
-                </a:solidFill>
-              </a:rPr>
-              <a:t>shortfall cover</a:t>
-            </a:r>
-            <a:endParaRPr lang="en-US" sz="1100" dirty="0"/>
-          </a:p>
-        </p:txBody>
-      </p:sp>
-      <p:sp>
-        <p:nvSpPr>
-          <p:cNvPr id="38" name="Text 36"/>
-          <p:cNvSpPr txBox="1"/>
-          <p:nvPr/>
-        </p:nvSpPr>
-        <p:spPr>
-          <a:xfrm>
-            <a:off x="6309360" y="4069080"/>
-            <a:ext cx="5486400" cy="1463040"/>
-          </a:xfrm>
-          <a:prstGeom prst="rect">
-            <a:avLst/>
-          </a:prstGeom>
-          <a:noFill/>
-          <a:ln/>
-        </p:spPr>
-        <p:txBody>
-          <a:bodyPr wrap="square" lIns="635" tIns="635" rIns="635" bIns="635" rtlCol="0" anchor="ctr"/>
+          <a:bodyPr wrap="square" lIns="635" tIns="635" rIns="635" bIns="635" rtlCol="0" anchor="t"/>
           <a:lstStyle/>
           <a:p>
             <a:pPr marL="342900" indent="-342900">
@@ -10418,7 +9892,7 @@
                   <a:schemeClr val="tx1"/>
                 </a:solidFill>
               </a:rPr>
-              <a:t>Merchant funds held in a segregated trust account</a:t>
+              <a:t>Settlement goes from the acquirer to each merchant's own bank account</a:t>
             </a:r>
             <a:endParaRPr lang="en-US" sz="1300" dirty="0"/>
           </a:p>
@@ -10436,7 +9910,7 @@
                   <a:schemeClr val="tx1"/>
                 </a:solidFill>
               </a:rPr>
-              <a:t>Daily safeguarding reconciliation, four-eyes sign-off</a:t>
+              <a:t>SPIN/MIPS never receives or holds merchant funds: there is no trust account to safeguard or reconcile</a:t>
             </a:r>
             <a:endParaRPr lang="en-US" sz="1300" dirty="0"/>
           </a:p>
@@ -10454,15 +9928,33 @@
                   <a:schemeClr val="tx1"/>
                 </a:solidFill>
               </a:rPr>
-              <a:t>Requires aggregation agreements with acquirers</a:t>
+              <a:t>MIPS fees are invoiced to merchants monthly, not deducted from settlements</a:t>
             </a:r>
             <a:endParaRPr lang="en-US" sz="1300" dirty="0"/>
           </a:p>
-        </p:txBody>
-      </p:sp>
-      <p:sp>
-        <p:nvSpPr>
-          <p:cNvPr id="39" name="Shape 37"/>
+          <a:p>
+            <a:pPr marL="342900" indent="-342900">
+              <a:spcAft>
+                <a:spcPts val="600"/>
+              </a:spcAft>
+              <a:buSzPct val="100000"/>
+              <a:buChar char="•"/>
+            </a:pPr>
+            <a:r>
+              <a:rPr lang="en-US" sz="1300" dirty="0">
+                <a:solidFill>
+                  <a:schemeClr val="tx1"/>
+                </a:solidFill>
+              </a:rPr>
+              <a:t>Collecting funds on behalf of merchants is not part of this application; it would require a safeguarding arrangement and daily reconciliation first</a:t>
+            </a:r>
+            <a:endParaRPr lang="en-US" sz="1300" dirty="0"/>
+          </a:p>
+        </p:txBody>
+      </p:sp>
+      <p:sp>
+        <p:nvSpPr>
+          <p:cNvPr id="23" name="Shape 21"/>
           <p:cNvSpPr/>
           <p:nvPr/>
         </p:nvSpPr>

</xml_diff>